<commit_message>
Update PowerPoint for song #130 in FUBC - Українські
</commit_message>
<xml_diff>
--- a/fubc-ua/130-Радість спасіння (Пісні Спасенних №127).pptx
+++ b/fubc-ua/130-Радість спасіння (Пісні Спасенних №127).pptx
@@ -596,7 +596,7 @@
           <a:p>
             <a:r>
               <a:rPr lang="en-US" dirty="0"/>
-              <a:t>1 · 1/1</a:t>
+              <a:t>1 · 1/1 · ||:4-4:||</a:t>
             </a:r>
             <a:endParaRPr lang="en-US" dirty="0"/>
           </a:p>
@@ -684,7 +684,7 @@
           <a:p>
             <a:r>
               <a:rPr lang="en-US" dirty="0"/>
-              <a:t>2 · 1/1</a:t>
+              <a:t>2 · 1/1 · ||:4-4:||</a:t>
             </a:r>
             <a:endParaRPr lang="en-US" dirty="0"/>
           </a:p>
@@ -772,7 +772,7 @@
           <a:p>
             <a:r>
               <a:rPr lang="en-US" dirty="0"/>
-              <a:t>3 · 1/1</a:t>
+              <a:t>3 · 1/1 · ||:4-4:||</a:t>
             </a:r>
             <a:endParaRPr lang="en-US" dirty="0"/>
           </a:p>
@@ -860,7 +860,7 @@
           <a:p>
             <a:r>
               <a:rPr lang="en-US" dirty="0"/>
-              <a:t>4 · 1/1</a:t>
+              <a:t>4 · 1/1 · ||:4-4:||</a:t>
             </a:r>
             <a:endParaRPr lang="en-US" dirty="0"/>
           </a:p>
@@ -948,7 +948,7 @@
           <a:p>
             <a:r>
               <a:rPr lang="en-US" dirty="0"/>
-              <a:t>5 · 1/1</a:t>
+              <a:t>5 · 1/1 · ||:4-4:||</a:t>
             </a:r>
             <a:endParaRPr lang="en-US" dirty="0"/>
           </a:p>
@@ -1519,6 +1519,9 @@
           <a:lstStyle/>
           <a:p>
             <a:pPr algn="ctr" indent="0" marL="0">
+              <a:lnSpc>
+                <a:spcPts val="6200"/>
+              </a:lnSpc>
               <a:buNone/>
             </a:pPr>
             <a:r>
@@ -1536,6 +1539,9 @@
           </a:p>
           <a:p>
             <a:pPr algn="ctr" indent="0" marL="0">
+              <a:lnSpc>
+                <a:spcPts val="6200"/>
+              </a:lnSpc>
               <a:buNone/>
             </a:pPr>
             <a:r>
@@ -1553,6 +1559,9 @@
           </a:p>
           <a:p>
             <a:pPr algn="ctr" indent="0" marL="0">
+              <a:lnSpc>
+                <a:spcPts val="6200"/>
+              </a:lnSpc>
               <a:buNone/>
             </a:pPr>
             <a:r>
@@ -1570,6 +1579,9 @@
           </a:p>
           <a:p>
             <a:pPr algn="ctr" indent="0" marL="0">
+              <a:lnSpc>
+                <a:spcPts val="6200"/>
+              </a:lnSpc>
               <a:buNone/>
             </a:pPr>
             <a:r>
@@ -1581,9 +1593,94 @@
                 <a:ea typeface="Arial" pitchFamily="34" charset="-122"/>
                 <a:cs typeface="Arial" pitchFamily="34" charset="-120"/>
               </a:rPr>
-              <a:t>||: Господу принесем. :||</a:t>
+              <a:t>Господу принесем.</a:t>
             </a:r>
             <a:endParaRPr lang="en-US" sz="5200" dirty="0"/>
+          </a:p>
+        </p:txBody>
+      </p:sp>
+      <p:sp>
+        <p:nvSpPr>
+          <p:cNvPr id="3" name="Shape 1"/>
+          <p:cNvSpPr/>
+          <p:nvPr/>
+        </p:nvSpPr>
+        <p:spPr>
+          <a:xfrm>
+            <a:off x="2718460" y="4340352"/>
+            <a:ext cx="0" cy="594360"/>
+          </a:xfrm>
+          <a:prstGeom prst="line">
+            <a:avLst/>
+          </a:prstGeom>
+          <a:noFill/>
+          <a:ln w="25400">
+            <a:solidFill>
+              <a:srgbClr val="8A8A8A"/>
+            </a:solidFill>
+            <a:prstDash val="solid"/>
+          </a:ln>
+        </p:spPr>
+      </p:sp>
+      <p:sp>
+        <p:nvSpPr>
+          <p:cNvPr id="4" name="Shape 2"/>
+          <p:cNvSpPr/>
+          <p:nvPr/>
+        </p:nvSpPr>
+        <p:spPr>
+          <a:xfrm>
+            <a:off x="9479636" y="4340352"/>
+            <a:ext cx="0" cy="594360"/>
+          </a:xfrm>
+          <a:prstGeom prst="line">
+            <a:avLst/>
+          </a:prstGeom>
+          <a:noFill/>
+          <a:ln w="25400">
+            <a:solidFill>
+              <a:srgbClr val="8A8A8A"/>
+            </a:solidFill>
+            <a:prstDash val="solid"/>
+          </a:ln>
+        </p:spPr>
+      </p:sp>
+      <p:sp>
+        <p:nvSpPr>
+          <p:cNvPr id="5" name="Text 3"/>
+          <p:cNvSpPr txBox="1"/>
+          <p:nvPr/>
+        </p:nvSpPr>
+        <p:spPr>
+          <a:xfrm>
+            <a:off x="9578696" y="4317492"/>
+            <a:ext cx="1097280" cy="640080"/>
+          </a:xfrm>
+          <a:prstGeom prst="rect">
+            <a:avLst/>
+          </a:prstGeom>
+          <a:noFill/>
+          <a:ln/>
+        </p:spPr>
+        <p:txBody>
+          <a:bodyPr wrap="square" lIns="0" tIns="0" rIns="0" bIns="0" rtlCol="0" anchor="ctr"/>
+          <a:lstStyle/>
+          <a:p>
+            <a:pPr algn="l" indent="0" marL="0">
+              <a:buNone/>
+            </a:pPr>
+            <a:r>
+              <a:rPr lang="en-US" sz="3600" b="1" dirty="0">
+                <a:solidFill>
+                  <a:srgbClr val="BBBBBB"/>
+                </a:solidFill>
+                <a:latin typeface="Arial" pitchFamily="34" charset="0"/>
+                <a:ea typeface="Arial" pitchFamily="34" charset="-122"/>
+                <a:cs typeface="Arial" pitchFamily="34" charset="-120"/>
+              </a:rPr>
+              <a:t>×2</a:t>
+            </a:r>
+            <a:endParaRPr lang="en-US" sz="3600" dirty="0"/>
           </a:p>
         </p:txBody>
       </p:sp>
@@ -1641,6 +1738,9 @@
           <a:lstStyle/>
           <a:p>
             <a:pPr algn="ctr" indent="0" marL="0">
+              <a:lnSpc>
+                <a:spcPts val="6200"/>
+              </a:lnSpc>
               <a:buNone/>
             </a:pPr>
             <a:r>
@@ -1658,6 +1758,9 @@
           </a:p>
           <a:p>
             <a:pPr algn="ctr" indent="0" marL="0">
+              <a:lnSpc>
+                <a:spcPts val="6200"/>
+              </a:lnSpc>
               <a:buNone/>
             </a:pPr>
             <a:r>
@@ -1675,6 +1778,9 @@
           </a:p>
           <a:p>
             <a:pPr algn="ctr" indent="0" marL="0">
+              <a:lnSpc>
+                <a:spcPts val="6200"/>
+              </a:lnSpc>
               <a:buNone/>
             </a:pPr>
             <a:r>
@@ -1692,6 +1798,9 @@
           </a:p>
           <a:p>
             <a:pPr algn="ctr" indent="0" marL="0">
+              <a:lnSpc>
+                <a:spcPts val="6200"/>
+              </a:lnSpc>
               <a:buNone/>
             </a:pPr>
             <a:r>
@@ -1703,9 +1812,94 @@
                 <a:ea typeface="Arial" pitchFamily="34" charset="-122"/>
                 <a:cs typeface="Arial" pitchFamily="34" charset="-120"/>
               </a:rPr>
-              <a:t>||: жити у небесах. :||</a:t>
+              <a:t>жити у небесах.</a:t>
             </a:r>
             <a:endParaRPr lang="en-US" sz="5200" dirty="0"/>
+          </a:p>
+        </p:txBody>
+      </p:sp>
+      <p:sp>
+        <p:nvSpPr>
+          <p:cNvPr id="3" name="Shape 1"/>
+          <p:cNvSpPr/>
+          <p:nvPr/>
+        </p:nvSpPr>
+        <p:spPr>
+          <a:xfrm>
+            <a:off x="3285414" y="4340352"/>
+            <a:ext cx="0" cy="594360"/>
+          </a:xfrm>
+          <a:prstGeom prst="line">
+            <a:avLst/>
+          </a:prstGeom>
+          <a:noFill/>
+          <a:ln w="25400">
+            <a:solidFill>
+              <a:srgbClr val="8A8A8A"/>
+            </a:solidFill>
+            <a:prstDash val="solid"/>
+          </a:ln>
+        </p:spPr>
+      </p:sp>
+      <p:sp>
+        <p:nvSpPr>
+          <p:cNvPr id="4" name="Shape 2"/>
+          <p:cNvSpPr/>
+          <p:nvPr/>
+        </p:nvSpPr>
+        <p:spPr>
+          <a:xfrm>
+            <a:off x="8912682" y="4340352"/>
+            <a:ext cx="0" cy="594360"/>
+          </a:xfrm>
+          <a:prstGeom prst="line">
+            <a:avLst/>
+          </a:prstGeom>
+          <a:noFill/>
+          <a:ln w="25400">
+            <a:solidFill>
+              <a:srgbClr val="8A8A8A"/>
+            </a:solidFill>
+            <a:prstDash val="solid"/>
+          </a:ln>
+        </p:spPr>
+      </p:sp>
+      <p:sp>
+        <p:nvSpPr>
+          <p:cNvPr id="5" name="Text 3"/>
+          <p:cNvSpPr txBox="1"/>
+          <p:nvPr/>
+        </p:nvSpPr>
+        <p:spPr>
+          <a:xfrm>
+            <a:off x="9011742" y="4317492"/>
+            <a:ext cx="1097280" cy="640080"/>
+          </a:xfrm>
+          <a:prstGeom prst="rect">
+            <a:avLst/>
+          </a:prstGeom>
+          <a:noFill/>
+          <a:ln/>
+        </p:spPr>
+        <p:txBody>
+          <a:bodyPr wrap="square" lIns="0" tIns="0" rIns="0" bIns="0" rtlCol="0" anchor="ctr"/>
+          <a:lstStyle/>
+          <a:p>
+            <a:pPr algn="l" indent="0" marL="0">
+              <a:buNone/>
+            </a:pPr>
+            <a:r>
+              <a:rPr lang="en-US" sz="3600" b="1" dirty="0">
+                <a:solidFill>
+                  <a:srgbClr val="BBBBBB"/>
+                </a:solidFill>
+                <a:latin typeface="Arial" pitchFamily="34" charset="0"/>
+                <a:ea typeface="Arial" pitchFamily="34" charset="-122"/>
+                <a:cs typeface="Arial" pitchFamily="34" charset="-120"/>
+              </a:rPr>
+              <a:t>×2</a:t>
+            </a:r>
+            <a:endParaRPr lang="en-US" sz="3600" dirty="0"/>
           </a:p>
         </p:txBody>
       </p:sp>
@@ -1763,6 +1957,9 @@
           <a:lstStyle/>
           <a:p>
             <a:pPr algn="ctr" indent="0" marL="0">
+              <a:lnSpc>
+                <a:spcPts val="6200"/>
+              </a:lnSpc>
               <a:buNone/>
             </a:pPr>
             <a:r>
@@ -1780,6 +1977,9 @@
           </a:p>
           <a:p>
             <a:pPr algn="ctr" indent="0" marL="0">
+              <a:lnSpc>
+                <a:spcPts val="6200"/>
+              </a:lnSpc>
               <a:buNone/>
             </a:pPr>
             <a:r>
@@ -1797,6 +1997,9 @@
           </a:p>
           <a:p>
             <a:pPr algn="ctr" indent="0" marL="0">
+              <a:lnSpc>
+                <a:spcPts val="6200"/>
+              </a:lnSpc>
               <a:buNone/>
             </a:pPr>
             <a:r>
@@ -1814,6 +2017,9 @@
           </a:p>
           <a:p>
             <a:pPr algn="ctr" indent="0" marL="0">
+              <a:lnSpc>
+                <a:spcPts val="6200"/>
+              </a:lnSpc>
               <a:buNone/>
             </a:pPr>
             <a:r>
@@ -1825,9 +2031,94 @@
                 <a:ea typeface="Arial" pitchFamily="34" charset="-122"/>
                 <a:cs typeface="Arial" pitchFamily="34" charset="-120"/>
               </a:rPr>
-              <a:t>||: від людства відвернув. :||</a:t>
+              <a:t>від людства відвернув.</a:t>
             </a:r>
             <a:endParaRPr lang="en-US" sz="5200" dirty="0"/>
+          </a:p>
+        </p:txBody>
+      </p:sp>
+      <p:sp>
+        <p:nvSpPr>
+          <p:cNvPr id="3" name="Shape 1"/>
+          <p:cNvSpPr/>
+          <p:nvPr/>
+        </p:nvSpPr>
+        <p:spPr>
+          <a:xfrm>
+            <a:off x="1975510" y="4340352"/>
+            <a:ext cx="0" cy="594360"/>
+          </a:xfrm>
+          <a:prstGeom prst="line">
+            <a:avLst/>
+          </a:prstGeom>
+          <a:noFill/>
+          <a:ln w="25400">
+            <a:solidFill>
+              <a:srgbClr val="8A8A8A"/>
+            </a:solidFill>
+            <a:prstDash val="solid"/>
+          </a:ln>
+        </p:spPr>
+      </p:sp>
+      <p:sp>
+        <p:nvSpPr>
+          <p:cNvPr id="4" name="Shape 2"/>
+          <p:cNvSpPr/>
+          <p:nvPr/>
+        </p:nvSpPr>
+        <p:spPr>
+          <a:xfrm>
+            <a:off x="10222586" y="4340352"/>
+            <a:ext cx="0" cy="594360"/>
+          </a:xfrm>
+          <a:prstGeom prst="line">
+            <a:avLst/>
+          </a:prstGeom>
+          <a:noFill/>
+          <a:ln w="25400">
+            <a:solidFill>
+              <a:srgbClr val="8A8A8A"/>
+            </a:solidFill>
+            <a:prstDash val="solid"/>
+          </a:ln>
+        </p:spPr>
+      </p:sp>
+      <p:sp>
+        <p:nvSpPr>
+          <p:cNvPr id="5" name="Text 3"/>
+          <p:cNvSpPr txBox="1"/>
+          <p:nvPr/>
+        </p:nvSpPr>
+        <p:spPr>
+          <a:xfrm>
+            <a:off x="10321646" y="4317492"/>
+            <a:ext cx="1097280" cy="640080"/>
+          </a:xfrm>
+          <a:prstGeom prst="rect">
+            <a:avLst/>
+          </a:prstGeom>
+          <a:noFill/>
+          <a:ln/>
+        </p:spPr>
+        <p:txBody>
+          <a:bodyPr wrap="square" lIns="0" tIns="0" rIns="0" bIns="0" rtlCol="0" anchor="ctr"/>
+          <a:lstStyle/>
+          <a:p>
+            <a:pPr algn="l" indent="0" marL="0">
+              <a:buNone/>
+            </a:pPr>
+            <a:r>
+              <a:rPr lang="en-US" sz="3600" b="1" dirty="0">
+                <a:solidFill>
+                  <a:srgbClr val="BBBBBB"/>
+                </a:solidFill>
+                <a:latin typeface="Arial" pitchFamily="34" charset="0"/>
+                <a:ea typeface="Arial" pitchFamily="34" charset="-122"/>
+                <a:cs typeface="Arial" pitchFamily="34" charset="-120"/>
+              </a:rPr>
+              <a:t>×2</a:t>
+            </a:r>
+            <a:endParaRPr lang="en-US" sz="3600" dirty="0"/>
           </a:p>
         </p:txBody>
       </p:sp>
@@ -1885,6 +2176,9 @@
           <a:lstStyle/>
           <a:p>
             <a:pPr algn="ctr" indent="0" marL="0">
+              <a:lnSpc>
+                <a:spcPts val="6200"/>
+              </a:lnSpc>
               <a:buNone/>
             </a:pPr>
             <a:r>
@@ -1902,6 +2196,9 @@
           </a:p>
           <a:p>
             <a:pPr algn="ctr" indent="0" marL="0">
+              <a:lnSpc>
+                <a:spcPts val="6200"/>
+              </a:lnSpc>
               <a:buNone/>
             </a:pPr>
             <a:r>
@@ -1919,6 +2216,9 @@
           </a:p>
           <a:p>
             <a:pPr algn="ctr" indent="0" marL="0">
+              <a:lnSpc>
+                <a:spcPts val="6200"/>
+              </a:lnSpc>
               <a:buNone/>
             </a:pPr>
             <a:r>
@@ -1936,6 +2236,9 @@
           </a:p>
           <a:p>
             <a:pPr algn="ctr" indent="0" marL="0">
+              <a:lnSpc>
+                <a:spcPts val="6200"/>
+              </a:lnSpc>
               <a:buNone/>
             </a:pPr>
             <a:r>
@@ -1947,9 +2250,94 @@
                 <a:ea typeface="Arial" pitchFamily="34" charset="-122"/>
                 <a:cs typeface="Arial" pitchFamily="34" charset="-120"/>
               </a:rPr>
-              <a:t>||: кровʼю навіки змив. :||</a:t>
+              <a:t>кровʼю навіки змив.</a:t>
             </a:r>
             <a:endParaRPr lang="en-US" sz="5200" dirty="0"/>
+          </a:p>
+        </p:txBody>
+      </p:sp>
+      <p:sp>
+        <p:nvSpPr>
+          <p:cNvPr id="3" name="Shape 1"/>
+          <p:cNvSpPr/>
+          <p:nvPr/>
+        </p:nvSpPr>
+        <p:spPr>
+          <a:xfrm>
+            <a:off x="2586380" y="4340352"/>
+            <a:ext cx="0" cy="594360"/>
+          </a:xfrm>
+          <a:prstGeom prst="line">
+            <a:avLst/>
+          </a:prstGeom>
+          <a:noFill/>
+          <a:ln w="25400">
+            <a:solidFill>
+              <a:srgbClr val="8A8A8A"/>
+            </a:solidFill>
+            <a:prstDash val="solid"/>
+          </a:ln>
+        </p:spPr>
+      </p:sp>
+      <p:sp>
+        <p:nvSpPr>
+          <p:cNvPr id="4" name="Shape 2"/>
+          <p:cNvSpPr/>
+          <p:nvPr/>
+        </p:nvSpPr>
+        <p:spPr>
+          <a:xfrm>
+            <a:off x="9611716" y="4340352"/>
+            <a:ext cx="0" cy="594360"/>
+          </a:xfrm>
+          <a:prstGeom prst="line">
+            <a:avLst/>
+          </a:prstGeom>
+          <a:noFill/>
+          <a:ln w="25400">
+            <a:solidFill>
+              <a:srgbClr val="8A8A8A"/>
+            </a:solidFill>
+            <a:prstDash val="solid"/>
+          </a:ln>
+        </p:spPr>
+      </p:sp>
+      <p:sp>
+        <p:nvSpPr>
+          <p:cNvPr id="5" name="Text 3"/>
+          <p:cNvSpPr txBox="1"/>
+          <p:nvPr/>
+        </p:nvSpPr>
+        <p:spPr>
+          <a:xfrm>
+            <a:off x="9710776" y="4317492"/>
+            <a:ext cx="1097280" cy="640080"/>
+          </a:xfrm>
+          <a:prstGeom prst="rect">
+            <a:avLst/>
+          </a:prstGeom>
+          <a:noFill/>
+          <a:ln/>
+        </p:spPr>
+        <p:txBody>
+          <a:bodyPr wrap="square" lIns="0" tIns="0" rIns="0" bIns="0" rtlCol="0" anchor="ctr"/>
+          <a:lstStyle/>
+          <a:p>
+            <a:pPr algn="l" indent="0" marL="0">
+              <a:buNone/>
+            </a:pPr>
+            <a:r>
+              <a:rPr lang="en-US" sz="3600" b="1" dirty="0">
+                <a:solidFill>
+                  <a:srgbClr val="BBBBBB"/>
+                </a:solidFill>
+                <a:latin typeface="Arial" pitchFamily="34" charset="0"/>
+                <a:ea typeface="Arial" pitchFamily="34" charset="-122"/>
+                <a:cs typeface="Arial" pitchFamily="34" charset="-120"/>
+              </a:rPr>
+              <a:t>×2</a:t>
+            </a:r>
+            <a:endParaRPr lang="en-US" sz="3600" dirty="0"/>
           </a:p>
         </p:txBody>
       </p:sp>
@@ -2007,6 +2395,9 @@
           <a:lstStyle/>
           <a:p>
             <a:pPr algn="ctr" indent="0" marL="0">
+              <a:lnSpc>
+                <a:spcPts val="6200"/>
+              </a:lnSpc>
               <a:buNone/>
             </a:pPr>
             <a:r>
@@ -2024,6 +2415,9 @@
           </a:p>
           <a:p>
             <a:pPr algn="ctr" indent="0" marL="0">
+              <a:lnSpc>
+                <a:spcPts val="6200"/>
+              </a:lnSpc>
               <a:buNone/>
             </a:pPr>
             <a:r>
@@ -2041,6 +2435,9 @@
           </a:p>
           <a:p>
             <a:pPr algn="ctr" indent="0" marL="0">
+              <a:lnSpc>
+                <a:spcPts val="6200"/>
+              </a:lnSpc>
               <a:buNone/>
             </a:pPr>
             <a:r>
@@ -2058,6 +2455,9 @@
           </a:p>
           <a:p>
             <a:pPr algn="ctr" indent="0" marL="0">
+              <a:lnSpc>
+                <a:spcPts val="6200"/>
+              </a:lnSpc>
               <a:buNone/>
             </a:pPr>
             <a:r>
@@ -2069,7 +2469,7 @@
                 <a:ea typeface="Arial" pitchFamily="34" charset="-122"/>
                 <a:cs typeface="Arial" pitchFamily="34" charset="-120"/>
               </a:rPr>
-              <a:t>||: а потім в небесах. :||</a:t>
+              <a:t>а потім в небесах.</a:t>
             </a:r>
             <a:endParaRPr lang="en-US" sz="5200" dirty="0"/>
           </a:p>
@@ -2077,7 +2477,92 @@
       </p:sp>
       <p:sp>
         <p:nvSpPr>
-          <p:cNvPr id="3" name="Text 1"/>
+          <p:cNvPr id="3" name="Shape 1"/>
+          <p:cNvSpPr/>
+          <p:nvPr/>
+        </p:nvSpPr>
+        <p:spPr>
+          <a:xfrm>
+            <a:off x="2893466" y="4340352"/>
+            <a:ext cx="0" cy="594360"/>
+          </a:xfrm>
+          <a:prstGeom prst="line">
+            <a:avLst/>
+          </a:prstGeom>
+          <a:noFill/>
+          <a:ln w="25400">
+            <a:solidFill>
+              <a:srgbClr val="8A8A8A"/>
+            </a:solidFill>
+            <a:prstDash val="solid"/>
+          </a:ln>
+        </p:spPr>
+      </p:sp>
+      <p:sp>
+        <p:nvSpPr>
+          <p:cNvPr id="4" name="Shape 2"/>
+          <p:cNvSpPr/>
+          <p:nvPr/>
+        </p:nvSpPr>
+        <p:spPr>
+          <a:xfrm>
+            <a:off x="9304630" y="4340352"/>
+            <a:ext cx="0" cy="594360"/>
+          </a:xfrm>
+          <a:prstGeom prst="line">
+            <a:avLst/>
+          </a:prstGeom>
+          <a:noFill/>
+          <a:ln w="25400">
+            <a:solidFill>
+              <a:srgbClr val="8A8A8A"/>
+            </a:solidFill>
+            <a:prstDash val="solid"/>
+          </a:ln>
+        </p:spPr>
+      </p:sp>
+      <p:sp>
+        <p:nvSpPr>
+          <p:cNvPr id="5" name="Text 3"/>
+          <p:cNvSpPr txBox="1"/>
+          <p:nvPr/>
+        </p:nvSpPr>
+        <p:spPr>
+          <a:xfrm>
+            <a:off x="9403690" y="4317492"/>
+            <a:ext cx="1097280" cy="640080"/>
+          </a:xfrm>
+          <a:prstGeom prst="rect">
+            <a:avLst/>
+          </a:prstGeom>
+          <a:noFill/>
+          <a:ln/>
+        </p:spPr>
+        <p:txBody>
+          <a:bodyPr wrap="square" lIns="0" tIns="0" rIns="0" bIns="0" rtlCol="0" anchor="ctr"/>
+          <a:lstStyle/>
+          <a:p>
+            <a:pPr algn="l" indent="0" marL="0">
+              <a:buNone/>
+            </a:pPr>
+            <a:r>
+              <a:rPr lang="en-US" sz="3600" b="1" dirty="0">
+                <a:solidFill>
+                  <a:srgbClr val="BBBBBB"/>
+                </a:solidFill>
+                <a:latin typeface="Arial" pitchFamily="34" charset="0"/>
+                <a:ea typeface="Arial" pitchFamily="34" charset="-122"/>
+                <a:cs typeface="Arial" pitchFamily="34" charset="-120"/>
+              </a:rPr>
+              <a:t>×2</a:t>
+            </a:r>
+            <a:endParaRPr lang="en-US" sz="3600" dirty="0"/>
+          </a:p>
+        </p:txBody>
+      </p:sp>
+      <p:sp>
+        <p:nvSpPr>
+          <p:cNvPr id="6" name="Text 4"/>
           <p:cNvSpPr txBox="1"/>
           <p:nvPr/>
         </p:nvSpPr>

</xml_diff>